<commit_message>
Mise à jour de la version anglaise de la piste de score
</commit_message>
<xml_diff>
--- a/pictures/Score-Track-en/Design-Score-Track.pptx
+++ b/pictures/Score-Track-en/Design-Score-Track.pptx
@@ -198,7 +198,7 @@
           <a:p>
             <a:fld id="{263B0988-6DB9-4E3D-B7FD-EFF3BCABE954}" type="datetimeFigureOut">
               <a:rPr lang="fr-FR" smtClean="0"/>
-              <a:t>15/04/2026</a:t>
+              <a:t>30/05/2026</a:t>
             </a:fld>
             <a:endParaRPr lang="fr-FR"/>
           </a:p>
@@ -696,7 +696,7 @@
           <a:p>
             <a:fld id="{588505E2-0C4C-443F-8F57-41958F504CA2}" type="datetimeFigureOut">
               <a:rPr lang="fr-FR" smtClean="0"/>
-              <a:t>15/04/2026</a:t>
+              <a:t>30/05/2026</a:t>
             </a:fld>
             <a:endParaRPr lang="fr-FR"/>
           </a:p>
@@ -894,7 +894,7 @@
           <a:p>
             <a:fld id="{588505E2-0C4C-443F-8F57-41958F504CA2}" type="datetimeFigureOut">
               <a:rPr lang="fr-FR" smtClean="0"/>
-              <a:t>15/04/2026</a:t>
+              <a:t>30/05/2026</a:t>
             </a:fld>
             <a:endParaRPr lang="fr-FR"/>
           </a:p>
@@ -1102,7 +1102,7 @@
           <a:p>
             <a:fld id="{588505E2-0C4C-443F-8F57-41958F504CA2}" type="datetimeFigureOut">
               <a:rPr lang="fr-FR" smtClean="0"/>
-              <a:t>15/04/2026</a:t>
+              <a:t>30/05/2026</a:t>
             </a:fld>
             <a:endParaRPr lang="fr-FR"/>
           </a:p>
@@ -1300,7 +1300,7 @@
           <a:p>
             <a:fld id="{588505E2-0C4C-443F-8F57-41958F504CA2}" type="datetimeFigureOut">
               <a:rPr lang="fr-FR" smtClean="0"/>
-              <a:t>15/04/2026</a:t>
+              <a:t>30/05/2026</a:t>
             </a:fld>
             <a:endParaRPr lang="fr-FR"/>
           </a:p>
@@ -1575,7 +1575,7 @@
           <a:p>
             <a:fld id="{588505E2-0C4C-443F-8F57-41958F504CA2}" type="datetimeFigureOut">
               <a:rPr lang="fr-FR" smtClean="0"/>
-              <a:t>15/04/2026</a:t>
+              <a:t>30/05/2026</a:t>
             </a:fld>
             <a:endParaRPr lang="fr-FR"/>
           </a:p>
@@ -1840,7 +1840,7 @@
           <a:p>
             <a:fld id="{588505E2-0C4C-443F-8F57-41958F504CA2}" type="datetimeFigureOut">
               <a:rPr lang="fr-FR" smtClean="0"/>
-              <a:t>15/04/2026</a:t>
+              <a:t>30/05/2026</a:t>
             </a:fld>
             <a:endParaRPr lang="fr-FR"/>
           </a:p>
@@ -2252,7 +2252,7 @@
           <a:p>
             <a:fld id="{588505E2-0C4C-443F-8F57-41958F504CA2}" type="datetimeFigureOut">
               <a:rPr lang="fr-FR" smtClean="0"/>
-              <a:t>15/04/2026</a:t>
+              <a:t>30/05/2026</a:t>
             </a:fld>
             <a:endParaRPr lang="fr-FR"/>
           </a:p>
@@ -2393,7 +2393,7 @@
           <a:p>
             <a:fld id="{588505E2-0C4C-443F-8F57-41958F504CA2}" type="datetimeFigureOut">
               <a:rPr lang="fr-FR" smtClean="0"/>
-              <a:t>15/04/2026</a:t>
+              <a:t>30/05/2026</a:t>
             </a:fld>
             <a:endParaRPr lang="fr-FR"/>
           </a:p>
@@ -2506,7 +2506,7 @@
           <a:p>
             <a:fld id="{588505E2-0C4C-443F-8F57-41958F504CA2}" type="datetimeFigureOut">
               <a:rPr lang="fr-FR" smtClean="0"/>
-              <a:t>15/04/2026</a:t>
+              <a:t>30/05/2026</a:t>
             </a:fld>
             <a:endParaRPr lang="fr-FR"/>
           </a:p>
@@ -2817,7 +2817,7 @@
           <a:p>
             <a:fld id="{588505E2-0C4C-443F-8F57-41958F504CA2}" type="datetimeFigureOut">
               <a:rPr lang="fr-FR" smtClean="0"/>
-              <a:t>15/04/2026</a:t>
+              <a:t>30/05/2026</a:t>
             </a:fld>
             <a:endParaRPr lang="fr-FR"/>
           </a:p>
@@ -3105,7 +3105,7 @@
           <a:p>
             <a:fld id="{588505E2-0C4C-443F-8F57-41958F504CA2}" type="datetimeFigureOut">
               <a:rPr lang="fr-FR" smtClean="0"/>
-              <a:t>15/04/2026</a:t>
+              <a:t>30/05/2026</a:t>
             </a:fld>
             <a:endParaRPr lang="fr-FR"/>
           </a:p>
@@ -3346,7 +3346,7 @@
           <a:p>
             <a:fld id="{588505E2-0C4C-443F-8F57-41958F504CA2}" type="datetimeFigureOut">
               <a:rPr lang="fr-FR" smtClean="0"/>
-              <a:t>15/04/2026</a:t>
+              <a:t>30/05/2026</a:t>
             </a:fld>
             <a:endParaRPr lang="fr-FR"/>
           </a:p>
@@ -7526,8 +7526,8 @@
           </p:nvSpPr>
           <p:spPr>
             <a:xfrm>
-              <a:off x="2428568" y="4216741"/>
-              <a:ext cx="1352790" cy="646331"/>
+              <a:off x="2375408" y="4216741"/>
+              <a:ext cx="1405950" cy="646331"/>
             </a:xfrm>
             <a:prstGeom prst="rect">
               <a:avLst/>
@@ -7640,8 +7640,8 @@
           </p:nvSpPr>
           <p:spPr>
             <a:xfrm>
-              <a:off x="2428568" y="4969052"/>
-              <a:ext cx="1352790" cy="646331"/>
+              <a:off x="2350008" y="4969052"/>
+              <a:ext cx="1431350" cy="646331"/>
             </a:xfrm>
             <a:prstGeom prst="rect">
               <a:avLst/>
@@ -7683,10 +7683,20 @@
             <a:p>
               <a:r>
                 <a:rPr lang="en-US" sz="1200" b="1" dirty="0">
+                  <a:solidFill>
+                    <a:srgbClr val="FF0000"/>
+                  </a:solidFill>
                   <a:latin typeface="Segoe UI" panose="020B0502040204020203" pitchFamily="34" charset="0"/>
                   <a:cs typeface="Segoe UI" panose="020B0502040204020203" pitchFamily="34" charset="0"/>
                 </a:rPr>
-                <a:t>End of turn with </a:t>
+                <a:t>Heralds gathered </a:t>
+              </a:r>
+              <a:r>
+                <a:rPr lang="en-US" sz="1200" b="1" dirty="0">
+                  <a:latin typeface="Segoe UI" panose="020B0502040204020203" pitchFamily="34" charset="0"/>
+                  <a:cs typeface="Segoe UI" panose="020B0502040204020203" pitchFamily="34" charset="0"/>
+                </a:rPr>
+                <a:t>at the Council ➔ </a:t>
               </a:r>
               <a:r>
                 <a:rPr lang="en-US" sz="1200" b="1" dirty="0">
@@ -7696,40 +7706,15 @@
                   <a:latin typeface="Segoe UI" panose="020B0502040204020203" pitchFamily="34" charset="0"/>
                   <a:cs typeface="Segoe UI" panose="020B0502040204020203" pitchFamily="34" charset="0"/>
                 </a:rPr>
-                <a:t>5 calamities </a:t>
-              </a:r>
-              <a:r>
-                <a:rPr lang="en-US" sz="1200" b="1" dirty="0">
-                  <a:latin typeface="Segoe UI" panose="020B0502040204020203" pitchFamily="34" charset="0"/>
-                  <a:cs typeface="Segoe UI" panose="020B0502040204020203" pitchFamily="34" charset="0"/>
-                </a:rPr>
-                <a:t>or more</a:t>
-              </a:r>
-              <a:r>
-                <a:rPr lang="fr-FR" sz="1200" b="1" dirty="0">
-                  <a:latin typeface="Segoe UI" panose="020B0502040204020203" pitchFamily="34" charset="0"/>
-                  <a:cs typeface="Segoe UI" panose="020B0502040204020203" pitchFamily="34" charset="0"/>
-                  <a:sym typeface="Wingdings" panose="05000000000000000000" pitchFamily="2" charset="2"/>
-                </a:rPr>
-                <a:t></a:t>
-              </a:r>
-              <a:r>
-                <a:rPr lang="fr-FR" sz="1200" b="1" dirty="0">
-                  <a:latin typeface="Segoe UI" panose="020B0502040204020203" pitchFamily="34" charset="0"/>
-                  <a:cs typeface="Segoe UI" panose="020B0502040204020203" pitchFamily="34" charset="0"/>
-                </a:rPr>
-                <a:t> </a:t>
-              </a:r>
-              <a:r>
-                <a:rPr lang="fr-FR" sz="1200" b="1" dirty="0">
-                  <a:solidFill>
-                    <a:srgbClr val="FF0000"/>
-                  </a:solidFill>
-                  <a:latin typeface="Segoe UI" panose="020B0502040204020203" pitchFamily="34" charset="0"/>
-                  <a:cs typeface="Segoe UI" panose="020B0502040204020203" pitchFamily="34" charset="0"/>
-                </a:rPr>
                 <a:t>STOP</a:t>
               </a:r>
+              <a:endParaRPr lang="fr-FR" sz="1200" b="1" dirty="0">
+                <a:solidFill>
+                  <a:srgbClr val="FF0000"/>
+                </a:solidFill>
+                <a:latin typeface="Segoe UI" panose="020B0502040204020203" pitchFamily="34" charset="0"/>
+                <a:cs typeface="Segoe UI" panose="020B0502040204020203" pitchFamily="34" charset="0"/>
+              </a:endParaRPr>
             </a:p>
           </p:txBody>
         </p:sp>

</xml_diff>